<commit_message>
docs: correct rental evidence and redesign report cover
</commit_message>
<xml_diff>
--- a/publication/Bergamo_LinkedIn_Carousel_EN_Final.pptx
+++ b/publication/Bergamo_LinkedIn_Carousel_EN_Final.pptx
@@ -1088,7 +1088,7 @@
           <a:lstStyle xmlns:a="http://schemas.openxmlformats.org/drawingml/2006/main"/>
           <a:p xmlns:a="http://schemas.openxmlformats.org/drawingml/2006/main">
             <a:r>
-              <a:t>2024 October nights 123460 regional vs123433 local release, cause unresolved. Listing registry data/listings.csv contains21 IDs, six primary offers. Sample asking median EUR900 is not a city estimate.</a:t>
+              <a:t>Research correction, 14 October 2026. All 21 saved records were reviewed; 17 numeric prices average EUR 1014.12, median EUR 1000, range EUR 700–1400, sample SD EUR 216.25. Four prices are missing. Geographic membership, fees and property duplication are not fully verified. EUR 900 remains a scenario assumption. A separate historical six-record subgroup has arithmetic mean EUR 1000 and median EUR 900. Source: data/listings.csv and results/listing-review.json.</a:t>
             </a:r>
             <a:endParaRPr/>
           </a:p>
@@ -3325,7 +3325,7 @@
                 <a:ea typeface="Aptos"/>
                 <a:cs typeface="Aptos"/>
               </a:rPr>
-              <a:t>A comparison of short-term and long-term renting in Bergamo, Italy</a:t>
+              <a:t>A Data-Driven Business Case Study on Rental Profitability in Bergamo</a:t>
             </a:r>
           </a:p>
         </p:txBody>
@@ -6215,7 +6215,7 @@
                 <a:ea typeface="Aptos"/>
                 <a:cs typeface="Aptos"/>
               </a:rPr>
-              <a:t>Scenario values, not city averages. STR: 180 nights, €115 gross rate, owner-paid cleaning. LTR: €900/month, 12 paid months. Actual gap €187.50.</a:t>
+              <a:t>Scenario values, not observed profits. LTR: €900/month, 12 paid months. The €900 input is an assumption, not a verified 21-listing mean.</a:t>
             </a:r>
           </a:p>
         </p:txBody>
@@ -8594,7 +8594,7 @@
                 <a:ea typeface="Aptos"/>
                 <a:cs typeface="Aptos"/>
               </a:rPr>
-              <a:t>21 candidates, 6 primary offers</a:t>
+              <a:t>21 records, 4 missing prices</a:t>
             </a:r>
           </a:p>
         </p:txBody>
@@ -8660,7 +8660,7 @@
                 <a:ea typeface="Aptos"/>
                 <a:cs typeface="Aptos"/>
               </a:rPr>
-              <a:t>Separate contract durations and serviced units. The 15–30 comparable-offer target remains unmet.</a:t>
+              <a:t>17 numeric rents average €1,014.12. Mixed areas and contracts do not verify a city-centre residential mean.</a:t>
             </a:r>
           </a:p>
         </p:txBody>

</xml_diff>

<commit_message>
Audit Bergamo rental listings and rebuild verified STR-LTR comparison
</commit_message>
<xml_diff>
--- a/publication/Bergamo_LinkedIn_Carousel_EN_Final.pptx
+++ b/publication/Bergamo_LinkedIn_Carousel_EN_Final.pptx
@@ -875,7 +875,7 @@
           <a:lstStyle xmlns:a="http://schemas.openxmlformats.org/drawingml/2006/main"/>
           <a:p xmlns:a="http://schemas.openxmlformats.org/drawingml/2006/main">
             <a:r>
-              <a:t>Exact annual cash values 6544.50 and 6732. Rounded display values use nearest EUR. Both assume eligible 21% tax; STR assumes 15.5% host fee. Fixed STR 3000, LTR 1800. Owner time, acquisition, financing and incremental preparation excluded. EUR115 is not a verified comparable gross ADR.</a:t>
+              <a:t>Manual online rental listing review,14October2026.96candidate rows:21original,20leads,55additional.14primary properties,mean894.2857142857143EUR/month,median850;40–65advertisedm2,furnished one-bedroom,selected central labels,explicit4+4.20-property target unmet.2confirmed duplicate clusters,6probable review pairs. New LTR6677.828571428572,STR6544.50,gap minus133.32857142857. Historical900rent/LTR6732 preserved separately. New thresholds183/202/221/240. Source https://github.com/pedramkj/bergamo-rental-strategy-analysis/blob/main/results/rental-market-analysis.json and data/rental/source-register.csv. Source accessibility does not verify apartment availability or signed rents.</a:t>
             </a:r>
             <a:endParaRPr/>
           </a:p>
@@ -946,7 +946,7 @@
           <a:lstStyle xmlns:a="http://schemas.openxmlformats.org/drawingml/2006/main"/>
           <a:p xmlns:a="http://schemas.openxmlformats.org/drawingml/2006/main">
             <a:r>
-              <a:t>Project scenario calculations: n*(gross ADR*0.635−20)−3000. Sensitivity assumptions, not confidence intervals or forecasts. EUR rounding is half-up in this slide (e.g. 6382.50 to 6383, 10135.50 to10136). LTR sensitivity and differential fixed costs are in the complete report.</a:t>
+              <a:t>Manual online rental listing review,14October2026.96candidate rows:21original,20leads,55additional.14primary properties,mean894.2857142857143EUR/month,median850;40–65advertisedm2,furnished one-bedroom,selected central labels,explicit4+4.20-property target unmet.2confirmed duplicate clusters,6probable review pairs. New LTR6677.828571428572,STR6544.50,gap minus133.32857142857. Historical900rent/LTR6732 preserved separately. New thresholds183/202/221/240. Source https://github.com/pedramkj/bergamo-rental-strategy-analysis/blob/main/results/rental-market-analysis.json and data/rental/source-register.csv. Source accessibility does not verify apartment availability or signed rents.</a:t>
             </a:r>
             <a:endParaRPr/>
           </a:p>
@@ -1017,7 +1017,7 @@
           <a:lstStyle xmlns:a="http://schemas.openxmlformats.org/drawingml/2006/main"/>
           <a:p xmlns:a="http://schemas.openxmlformats.org/drawingml/2006/main">
             <a:r>
-              <a:t>No setup: ceil((6732+3000)/53.025)=184. EUR15000 incremental setup/five years: ceil((6732+3000+3000)/53.025)=241. Five-year recovery is illustrative and undiscounted, not observed investor preference.</a:t>
+              <a:t>Manual online rental listing review,14October2026.96candidate rows:21original,20leads,55additional.14primary properties,mean894.2857142857143EUR/month,median850;40–65advertisedm2,furnished one-bedroom,selected central labels,explicit4+4.20-property target unmet.2confirmed duplicate clusters,6probable review pairs. New LTR6677.828571428572,STR6544.50,gap minus133.32857142857. Historical900rent/LTR6732 preserved separately. New thresholds183/202/221/240. Source https://github.com/pedramkj/bergamo-rental-strategy-analysis/blob/main/results/rental-market-analysis.json and data/rental/source-register.csv. Source accessibility does not verify apartment availability or signed rents.</a:t>
             </a:r>
             <a:endParaRPr/>
           </a:p>
@@ -1088,7 +1088,7 @@
           <a:lstStyle xmlns:a="http://schemas.openxmlformats.org/drawingml/2006/main"/>
           <a:p xmlns:a="http://schemas.openxmlformats.org/drawingml/2006/main">
             <a:r>
-              <a:t>Research correction, 14 October 2026. All 21 saved records were reviewed; 17 numeric prices average EUR 1014.12, median EUR 1000, range EUR 700–1400, sample SD EUR 216.25. Four prices are missing. Geographic membership, fees and property duplication are not fully verified. EUR 900 remains a scenario assumption. A separate historical six-record subgroup has arithmetic mean EUR 1000 and median EUR 900. Source: data/listings.csv and results/listing-review.json.</a:t>
+              <a:t>Manual online rental listing review,14October2026.96candidate rows:21original,20leads,55additional.14primary properties,mean894.2857142857143EUR/month,median850;40–65advertisedm2,furnished one-bedroom,selected central labels,explicit4+4.20-property target unmet.2confirmed duplicate clusters,6probable review pairs. New LTR6677.828571428572,STR6544.50,gap minus133.32857142857. Historical900rent/LTR6732 preserved separately. New thresholds183/202/221/240. Source https://github.com/pedramkj/bergamo-rental-strategy-analysis/blob/main/results/rental-market-analysis.json and data/rental/source-register.csv. Source accessibility does not verify apartment availability or signed rents.</a:t>
             </a:r>
             <a:endParaRPr/>
           </a:p>
@@ -1159,7 +1159,7 @@
           <a:lstStyle xmlns:a="http://schemas.openxmlformats.org/drawingml/2006/main"/>
           <a:p xmlns:a="http://schemas.openxmlformats.org/drawingml/2006/main">
             <a:r>
-              <a:t>Project: https://github.com/pedramkj/bergamo-rental-strategy-analysis . Author: https://www.linkedin.com/in/pedram-kojouri/ . No general city-wide conversion recommendation. Full report contains assumptions, source URLs, limitations and unresolved legal eligibility checks.</a:t>
+              <a:t>Manual online rental listing review,14October2026.96candidate rows:21original,20leads,55additional.14primary properties,mean894.2857142857143EUR/month,median850;40–65advertisedm2,furnished one-bedroom,selected central labels,explicit4+4.20-property target unmet.2confirmed duplicate clusters,6probable review pairs. New LTR6677.828571428572,STR6544.50,gap minus133.32857142857. Historical900rent/LTR6732 preserved separately. New thresholds183/202/221/240. Source https://github.com/pedramkj/bergamo-rental-strategy-analysis/blob/main/results/rental-market-analysis.json and data/rental/source-register.csv. Source accessibility does not verify apartment availability or signed rents.</a:t>
             </a:r>
             <a:endParaRPr/>
           </a:p>
@@ -2645,16 +2645,16 @@
                 <c:formatCode>0</c:formatCode>
                 <c:ptCount val="4"/>
                 <c:pt idx="0">
-                  <c:v>184</c:v>
+                  <c:v>183</c:v>
                 </c:pt>
                 <c:pt idx="1">
-                  <c:v>203</c:v>
+                  <c:v>202</c:v>
                 </c:pt>
                 <c:pt idx="2">
-                  <c:v>222</c:v>
+                  <c:v>221</c:v>
                 </c:pt>
                 <c:pt idx="3">
-                  <c:v>241</c:v>
+                  <c:v>240</c:v>
                 </c:pt>
               </c:numCache>
             </c:numRef>
@@ -6149,7 +6149,7 @@
                 <a:ea typeface="Aptos"/>
                 <a:cs typeface="Aptos"/>
               </a:rPr>
-              <a:t>€6,732</a:t>
+              <a:t>€6,678</a:t>
             </a:r>
           </a:p>
         </p:txBody>
@@ -6215,7 +6215,7 @@
                 <a:ea typeface="Aptos"/>
                 <a:cs typeface="Aptos"/>
               </a:rPr>
-              <a:t>Scenario values, not observed profits. LTR: €900/month, 12 paid months. The €900 input is an assumption, not a verified 21-listing mean.</a:t>
+              <a:t>Modelled cash. LTR uses the unrounded 14-property mean of €894.29/month and 12 paid months. The full report preserves the historical €900 scenario.</a:t>
             </a:r>
           </a:p>
         </p:txBody>
@@ -7216,7 +7216,7 @@
                 <a:ea typeface="Aptos"/>
                 <a:cs typeface="Aptos"/>
               </a:rPr>
-              <a:t>Long-term baseline: €6,732/year</a:t>
+              <a:t>Long-term scenario: €6,678/year</a:t>
             </a:r>
           </a:p>
         </p:txBody>
@@ -7883,7 +7883,7 @@
                 <a:ea typeface="Aptos"/>
                 <a:cs typeface="Aptos"/>
               </a:rPr>
-              <a:t>Source: scenario model. Additional setup cost above the long-term alternative, recovered over five years. Thresholds round upward.</a:t>
+              <a:t>Sample-mean LTR alternative. Incremental setup recovered over five years. At €115/night: 183 nights without extra setup, 240 with €15,000.</a:t>
             </a:r>
           </a:p>
         </p:txBody>
@@ -8044,7 +8044,7 @@
                 <a:ea typeface="Aptos"/>
                 <a:cs typeface="Aptos"/>
               </a:rPr>
-              <a:t>RESEARCH CHALLENGES</a:t>
+              <a:t>RENTAL MARKET EVIDENCE</a:t>
             </a:r>
             <a:endParaRPr sz="900"/>
           </a:p>
@@ -8307,7 +8307,7 @@
                 <a:ea typeface="Aptos"/>
                 <a:cs typeface="Aptos"/>
               </a:rPr>
-              <a:t>The difficult part</a:t>
+              <a:t>A selected sample of</a:t>
             </a:r>
           </a:p>
           <a:p xmlns:a="http://schemas.openxmlformats.org/drawingml/2006/main">
@@ -8330,7 +8330,7 @@
                 <a:ea typeface="Aptos"/>
                 <a:cs typeface="Aptos"/>
               </a:rPr>
-              <a:t>was comparability</a:t>
+              <a:t>14 comparable properties</a:t>
             </a:r>
           </a:p>
         </p:txBody>
@@ -8396,7 +8396,7 @@
                 <a:ea typeface="Aptos"/>
                 <a:cs typeface="Aptos"/>
               </a:rPr>
-              <a:t>Data validation and assumptions determine how much we can conclude.</a:t>
+              <a:t>Central furnished one-bedroom offers with an explicit 4+4 contract.</a:t>
             </a:r>
           </a:p>
         </p:txBody>
@@ -8462,7 +8462,7 @@
                 <a:ea typeface="Aptos"/>
                 <a:cs typeface="Aptos"/>
               </a:rPr>
-              <a:t>27 guest nights</a:t>
+              <a:t>€894.29 mean base rent</a:t>
             </a:r>
           </a:p>
         </p:txBody>
@@ -8528,7 +8528,7 @@
                 <a:ea typeface="Aptos"/>
                 <a:cs typeface="Aptos"/>
               </a:rPr>
-              <a:t>October discrepancy between two official 2024 releases. Kept visible instead of silently pooled.</a:t>
+              <a:t>Median €850/month. Asking rents exclude separately billed charges. This convenience sample does not represent all Bergamo.</a:t>
             </a:r>
           </a:p>
         </p:txBody>
@@ -8594,7 +8594,7 @@
                 <a:ea typeface="Aptos"/>
                 <a:cs typeface="Aptos"/>
               </a:rPr>
-              <a:t>21 records, 4 missing prices</a:t>
+              <a:t>96 candidates reviewed</a:t>
             </a:r>
           </a:p>
         </p:txBody>
@@ -8660,7 +8660,7 @@
                 <a:ea typeface="Aptos"/>
                 <a:cs typeface="Aptos"/>
               </a:rPr>
-              <a:t>17 numeric rents average €1,014.12. Mixed areas and contracts do not verify a city-centre residential mean.</a:t>
+              <a:t>21 original records, 20 leads and 55 additional offers. Two duplicate clusters confirmed. The 20-property target remained unmet.</a:t>
             </a:r>
           </a:p>
         </p:txBody>
@@ -8726,7 +8726,7 @@
                 <a:ea typeface="Aptos"/>
                 <a:cs typeface="Aptos"/>
               </a:rPr>
-              <a:t>Skills demonstrated: source reconciliation, time-series joining, financial modelling and sensitivity analysis.</a:t>
+              <a:t>Manual online listing review. Sources, identity decisions and all unresolved records are available in the complete audit.</a:t>
             </a:r>
           </a:p>
         </p:txBody>
@@ -9239,7 +9239,7 @@
                 <a:ea typeface="Aptos"/>
                 <a:cs typeface="Aptos"/>
               </a:rPr>
-              <a:t>The evidence supports testing the economics of the same property before conversion.</a:t>
+              <a:t>The sample-mean scenario leaves a €133.33 annual gap. Property-level bookings, costs and paid months can reverse the ranking.</a:t>
             </a:r>
           </a:p>
         </p:txBody>

</xml_diff>